<commit_message>
Redesign handcrafted features slide: two columns, larger figures
Split the cramped two-graph layout into a kept (left) vs rejected (right)
two-column design so each figure is readable.

Co-Authored-By: Claude Opus 4.8 <noreply@anthropic.com>
</commit_message>
<xml_diff>
--- a/presentation/Himalaya_soutenance.pptx
+++ b/presentation/Himalaya_soutenance.pptx
@@ -5354,8 +5354,8 @@
         </p:nvSpPr>
         <p:spPr>
           <a:xfrm>
-            <a:off x="502920" y="1325880"/>
-            <a:ext cx="5212080" cy="5212080"/>
+            <a:off x="457200" y="1207008"/>
+            <a:ext cx="5486400" cy="1417320"/>
           </a:xfrm>
           <a:prstGeom prst="rect">
             <a:avLst/>
@@ -5373,11 +5373,11 @@
                 <a:spcPts val="0"/>
               </a:spcBef>
               <a:spcAft>
-                <a:spcPts val="800"/>
+                <a:spcPts val="600"/>
               </a:spcAft>
             </a:pPr>
             <a:r>
-              <a:rPr sz="1800" b="1">
+              <a:rPr sz="1900" b="1">
                 <a:solidFill>
                   <a:srgbClr val="27AE60"/>
                 </a:solidFill>
@@ -5391,7 +5391,7 @@
                 <a:spcPts val="0"/>
               </a:spcBef>
               <a:spcAft>
-                <a:spcPts val="800"/>
+                <a:spcPts val="600"/>
               </a:spcAft>
             </a:pPr>
             <a:r>
@@ -5400,97 +5400,7 @@
                   <a:srgbClr val="222222"/>
                 </a:solidFill>
               </a:rPr>
-              <a:t>–  GARDÉE. À équipe égale, le succès monte avec la proportion de Sherpas : 49 % (ratio&lt;0,5) -&gt; 64 % (0,5–1).</a:t>
-            </a:r>
-          </a:p>
-          <a:p>
-            <a:pPr>
-              <a:spcBef>
-                <a:spcPts val="0"/>
-              </a:spcBef>
-              <a:spcAft>
-                <a:spcPts val="800"/>
-              </a:spcAft>
-            </a:pPr>
-            <a:r>
-              <a:rPr sz="1800" b="1">
-                <a:solidFill>
-                  <a:srgbClr val="C0392B"/>
-                </a:solidFill>
-              </a:rPr>
-              <a:t>o2used × season</a:t>
-            </a:r>
-          </a:p>
-          <a:p>
-            <a:pPr lvl="1">
-              <a:spcBef>
-                <a:spcPts val="0"/>
-              </a:spcBef>
-              <a:spcAft>
-                <a:spcPts val="800"/>
-              </a:spcAft>
-            </a:pPr>
-            <a:r>
-              <a:rPr sz="1500" b="0">
-                <a:solidFill>
-                  <a:srgbClr val="222222"/>
-                </a:solidFill>
-              </a:rPr>
-              <a:t>–  REJETÉE. Fausse interaction : l'effet venait du sommet tenté (Everest au printemps), pas de la saison. Variable confondante.</a:t>
-            </a:r>
-          </a:p>
-          <a:p>
-            <a:pPr>
-              <a:spcBef>
-                <a:spcPts val="0"/>
-              </a:spcBef>
-              <a:spcAft>
-                <a:spcPts val="800"/>
-              </a:spcAft>
-            </a:pPr>
-            <a:r>
-              <a:rPr sz="1800" b="1">
-                <a:solidFill>
-                  <a:srgbClr val="C0392B"/>
-                </a:solidFill>
-              </a:rPr>
-              <a:t>rope_bool (corde fixe posée)</a:t>
-            </a:r>
-          </a:p>
-          <a:p>
-            <a:pPr lvl="1">
-              <a:spcBef>
-                <a:spcPts val="0"/>
-              </a:spcBef>
-              <a:spcAft>
-                <a:spcPts val="800"/>
-              </a:spcAft>
-            </a:pPr>
-            <a:r>
-              <a:rPr sz="1500" b="0">
-                <a:solidFill>
-                  <a:srgbClr val="222222"/>
-                </a:solidFill>
-              </a:rPr>
-              <a:t>–  REJETÉE. Aucun signal (55 % vs 54 %), et risque de leakage (posée pendant l'ascension).</a:t>
-            </a:r>
-          </a:p>
-          <a:p>
-            <a:pPr>
-              <a:spcBef>
-                <a:spcPts val="0"/>
-              </a:spcBef>
-              <a:spcAft>
-                <a:spcPts val="800"/>
-              </a:spcAft>
-            </a:pPr>
-            <a:r>
-              <a:rPr sz="1500" b="1">
-                <a:solidFill>
-                  <a:srgbClr val="1F3A5F"/>
-                </a:solidFill>
-              </a:rPr>
-              <a:t>Rejeter ses propres hypothèses = cœur de la démarche scientifique.</a:t>
+              <a:t>–  GARDÉE. À équipe égale, le succès monte avec la proportion de Sherpas : 49 % (ratio &lt; 0,5)  -&gt;  64 % (0,5–1).</a:t>
             </a:r>
           </a:p>
         </p:txBody>
@@ -5511,17 +5421,128 @@
         </p:blipFill>
         <p:spPr>
           <a:xfrm>
-            <a:off x="5806440" y="2215661"/>
-            <a:ext cx="3154680" cy="2426676"/>
+            <a:off x="1060704" y="2651760"/>
+            <a:ext cx="4279392" cy="3291840"/>
           </a:xfrm>
           <a:prstGeom prst="rect">
             <a:avLst/>
           </a:prstGeom>
         </p:spPr>
       </p:pic>
+      <p:sp>
+        <p:nvSpPr>
+          <p:cNvPr id="8" name="TextBox 7"/>
+          <p:cNvSpPr txBox="1"/>
+          <p:nvPr/>
+        </p:nvSpPr>
+        <p:spPr>
+          <a:xfrm>
+            <a:off x="502920" y="5989320"/>
+            <a:ext cx="5394960" cy="365760"/>
+          </a:xfrm>
+          <a:prstGeom prst="rect">
+            <a:avLst/>
+          </a:prstGeom>
+          <a:noFill/>
+        </p:spPr>
+        <p:txBody>
+          <a:bodyPr wrap="square">
+            <a:spAutoFit/>
+          </a:bodyPr>
+          <a:lstStyle/>
+          <a:p>
+            <a:pPr algn="ctr"/>
+            <a:r>
+              <a:rPr sz="1100" i="1">
+                <a:solidFill>
+                  <a:srgbClr val="555555"/>
+                </a:solidFill>
+              </a:rPr>
+              <a:t>GARDÉE : à équipe égale, le ratio de Sherpas fait la différence.</a:t>
+            </a:r>
+          </a:p>
+        </p:txBody>
+      </p:sp>
+      <p:sp>
+        <p:nvSpPr>
+          <p:cNvPr id="9" name="TextBox 8"/>
+          <p:cNvSpPr txBox="1"/>
+          <p:nvPr/>
+        </p:nvSpPr>
+        <p:spPr>
+          <a:xfrm>
+            <a:off x="6263640" y="1207008"/>
+            <a:ext cx="5486400" cy="1417320"/>
+          </a:xfrm>
+          <a:prstGeom prst="rect">
+            <a:avLst/>
+          </a:prstGeom>
+          <a:noFill/>
+        </p:spPr>
+        <p:txBody>
+          <a:bodyPr wrap="square">
+            <a:spAutoFit/>
+          </a:bodyPr>
+          <a:lstStyle/>
+          <a:p>
+            <a:pPr>
+              <a:spcBef>
+                <a:spcPts val="0"/>
+              </a:spcBef>
+              <a:spcAft>
+                <a:spcPts val="400"/>
+              </a:spcAft>
+            </a:pPr>
+            <a:r>
+              <a:rPr sz="1900" b="1">
+                <a:solidFill>
+                  <a:srgbClr val="C0392B"/>
+                </a:solidFill>
+              </a:rPr>
+              <a:t>Deux hypothèses rejetées</a:t>
+            </a:r>
+          </a:p>
+          <a:p>
+            <a:pPr lvl="1">
+              <a:spcBef>
+                <a:spcPts val="0"/>
+              </a:spcBef>
+              <a:spcAft>
+                <a:spcPts val="400"/>
+              </a:spcAft>
+            </a:pPr>
+            <a:r>
+              <a:rPr sz="1500" b="0">
+                <a:solidFill>
+                  <a:srgbClr val="222222"/>
+                </a:solidFill>
+              </a:rPr>
+              <a:t>–  o2used × season : fausse interaction. La vraie cause est le sommet tenté (Everest au printemps), pas la saison.</a:t>
+            </a:r>
+          </a:p>
+          <a:p>
+            <a:pPr lvl="1">
+              <a:spcBef>
+                <a:spcPts val="0"/>
+              </a:spcBef>
+              <a:spcAft>
+                <a:spcPts val="400"/>
+              </a:spcAft>
+            </a:pPr>
+            <a:r>
+              <a:rPr sz="1500" b="0">
+                <a:solidFill>
+                  <a:srgbClr val="222222"/>
+                </a:solidFill>
+              </a:rPr>
+              <a:t>–  rope_bool : aucun signal (55 % vs 54 %), et corde posée pendant l'ascension (leakage).</a:t>
+            </a:r>
+          </a:p>
+        </p:txBody>
+      </p:sp>
       <p:pic>
         <p:nvPicPr>
-          <p:cNvPr id="8" name="Picture 7" descr="02_interaction_o2_saison.png"/>
+          <p:cNvPr id="10" name="Picture 9" descr="02_interaction_o2_saison.png"/>
           <p:cNvPicPr>
             <a:picLocks noChangeAspect="1"/>
           </p:cNvPicPr>
@@ -5535,8 +5556,8 @@
         </p:blipFill>
         <p:spPr>
           <a:xfrm>
-            <a:off x="8915400" y="2414995"/>
-            <a:ext cx="3154680" cy="2028008"/>
+            <a:off x="6446520" y="2651760"/>
+            <a:ext cx="5120640" cy="3291840"/>
           </a:xfrm>
           <a:prstGeom prst="rect">
             <a:avLst/>
@@ -5545,14 +5566,14 @@
       </p:pic>
       <p:sp>
         <p:nvSpPr>
-          <p:cNvPr id="9" name="TextBox 8"/>
+          <p:cNvPr id="11" name="TextBox 10"/>
           <p:cNvSpPr txBox="1"/>
           <p:nvPr/>
         </p:nvSpPr>
         <p:spPr>
           <a:xfrm>
-            <a:off x="5806440" y="5623560"/>
-            <a:ext cx="3154680" cy="365760"/>
+            <a:off x="6309360" y="5989320"/>
+            <a:ext cx="5394960" cy="365760"/>
           </a:xfrm>
           <a:prstGeom prst="rect">
             <a:avLst/>
@@ -5572,21 +5593,21 @@
                   <a:srgbClr val="555555"/>
                 </a:solidFill>
               </a:rPr>
-              <a:t>GARDÉE : le ratio de Sherpas compte.</a:t>
-            </a:r>
-          </a:p>
-        </p:txBody>
-      </p:sp>
-      <p:sp>
-        <p:nvSpPr>
-          <p:cNvPr id="10" name="TextBox 9"/>
+              <a:t>REJETÉE : l'« interaction » O2 × saison n'est qu'un artefact.</a:t>
+            </a:r>
+          </a:p>
+        </p:txBody>
+      </p:sp>
+      <p:sp>
+        <p:nvSpPr>
+          <p:cNvPr id="12" name="TextBox 11"/>
           <p:cNvSpPr txBox="1"/>
           <p:nvPr/>
         </p:nvSpPr>
         <p:spPr>
           <a:xfrm>
-            <a:off x="8915400" y="5623560"/>
-            <a:ext cx="3154680" cy="365760"/>
+            <a:off x="457200" y="6446520"/>
+            <a:ext cx="8778240" cy="310896"/>
           </a:xfrm>
           <a:prstGeom prst="rect">
             <a:avLst/>
@@ -5594,26 +5615,26 @@
           <a:noFill/>
         </p:spPr>
         <p:txBody>
-          <a:bodyPr wrap="square">
+          <a:bodyPr wrap="none">
             <a:spAutoFit/>
           </a:bodyPr>
           <a:lstStyle/>
           <a:p>
             <a:pPr algn="ctr"/>
             <a:r>
-              <a:rPr sz="1100" i="1">
-                <a:solidFill>
-                  <a:srgbClr val="555555"/>
-                </a:solidFill>
-              </a:rPr>
-              <a:t>REJETÉE : « interaction » = artefact.</a:t>
-            </a:r>
-          </a:p>
-        </p:txBody>
-      </p:sp>
-      <p:sp>
-        <p:nvSpPr>
-          <p:cNvPr id="11" name="Rounded Rectangle 10"/>
+              <a:rPr sz="1200" i="1" b="1">
+                <a:solidFill>
+                  <a:srgbClr val="1F3A5F"/>
+                </a:solidFill>
+              </a:rPr>
+              <a:t>Rejeter ses propres hypothèses quand les données les contredisent = cœur de la démarche scientifique.</a:t>
+            </a:r>
+          </a:p>
+        </p:txBody>
+      </p:sp>
+      <p:sp>
+        <p:nvSpPr>
+          <p:cNvPr id="13" name="Rounded Rectangle 12"/>
           <p:cNvSpPr/>
           <p:nvPr/>
         </p:nvSpPr>

</xml_diff>